<commit_message>
Updates & Changelog Slide
</commit_message>
<xml_diff>
--- a/documentation/presentation/BG-Presentation.pptx
+++ b/documentation/presentation/BG-Presentation.pptx
@@ -5,7 +5,7 @@
     <p:sldMasterId id="2147483648" r:id="rId1"/>
   </p:sldMasterIdLst>
   <p:notesMasterIdLst>
-    <p:notesMasterId r:id="rId13"/>
+    <p:notesMasterId r:id="rId14"/>
   </p:notesMasterIdLst>
   <p:sldIdLst>
     <p:sldId id="256" r:id="rId2"/>
@@ -15,10 +15,11 @@
     <p:sldId id="263" r:id="rId6"/>
     <p:sldId id="264" r:id="rId7"/>
     <p:sldId id="265" r:id="rId8"/>
-    <p:sldId id="266" r:id="rId9"/>
-    <p:sldId id="267" r:id="rId10"/>
-    <p:sldId id="258" r:id="rId11"/>
-    <p:sldId id="259" r:id="rId12"/>
+    <p:sldId id="268" r:id="rId9"/>
+    <p:sldId id="266" r:id="rId10"/>
+    <p:sldId id="267" r:id="rId11"/>
+    <p:sldId id="258" r:id="rId12"/>
+    <p:sldId id="259" r:id="rId13"/>
   </p:sldIdLst>
   <p:sldSz cx="12192000" cy="6858000"/>
   <p:notesSz cx="6858000" cy="9144000"/>
@@ -207,7 +208,7 @@
           <a:p>
             <a:fld id="{E52C5099-0BBB-0E4D-97DC-F013207E5024}" type="datetimeFigureOut">
               <a:rPr lang="en-US" smtClean="0"/>
-              <a:t>11/14/25</a:t>
+              <a:t>11/15/25</a:t>
             </a:fld>
             <a:endParaRPr lang="en-US"/>
           </a:p>
@@ -637,7 +638,7 @@
           <a:p>
             <a:fld id="{57EED97B-6CE9-6341-B85C-A7AC117F7DF0}" type="slidenum">
               <a:rPr lang="en-US" smtClean="0"/>
-              <a:t>8</a:t>
+              <a:t>9</a:t>
             </a:fld>
             <a:endParaRPr lang="en-US"/>
           </a:p>
@@ -1235,7 +1236,7 @@
           <a:p>
             <a:fld id="{44774AEE-31DE-408D-A86C-C9765183083C}" type="datetimeFigureOut">
               <a:rPr lang="en-US" smtClean="0"/>
-              <a:t>11/14/25</a:t>
+              <a:t>11/15/25</a:t>
             </a:fld>
             <a:endParaRPr lang="en-US"/>
           </a:p>
@@ -2079,6 +2080,529 @@
         <p:cNvPr id="1" name="">
           <a:extLst>
             <a:ext uri="{FF2B5EF4-FFF2-40B4-BE49-F238E27FC236}">
+              <a16:creationId xmlns:a16="http://schemas.microsoft.com/office/drawing/2014/main" id="{C33651CE-39D7-A105-5EEF-AED97F7BF0E2}"/>
+            </a:ext>
+          </a:extLst>
+        </p:cNvPr>
+        <p:cNvGrpSpPr/>
+        <p:nvPr/>
+      </p:nvGrpSpPr>
+      <p:grpSpPr>
+        <a:xfrm>
+          <a:off x="0" y="0"/>
+          <a:ext cx="0" cy="0"/>
+          <a:chOff x="0" y="0"/>
+          <a:chExt cx="0" cy="0"/>
+        </a:xfrm>
+      </p:grpSpPr>
+      <p:pic>
+        <p:nvPicPr>
+          <p:cNvPr id="18" name="Picture 2" descr="High resolution abstract digital background with connected white dots and multicolor light effects on black background">
+            <a:extLst>
+              <a:ext uri="{FF2B5EF4-FFF2-40B4-BE49-F238E27FC236}">
+                <a16:creationId xmlns:a16="http://schemas.microsoft.com/office/drawing/2014/main" id="{47E619C3-2E5E-6FFD-2438-570D3CB917BC}"/>
+              </a:ext>
+            </a:extLst>
+          </p:cNvPr>
+          <p:cNvPicPr>
+            <a:picLocks noChangeAspect="1" noChangeArrowheads="1"/>
+          </p:cNvPicPr>
+          <p:nvPr/>
+        </p:nvPicPr>
+        <p:blipFill rotWithShape="1">
+          <a:blip r:embed="rId2">
+            <a:extLst>
+              <a:ext uri="{28A0092B-C50C-407E-A947-70E740481C1C}">
+                <a14:useLocalDpi xmlns:a14="http://schemas.microsoft.com/office/drawing/2010/main" val="0"/>
+              </a:ext>
+            </a:extLst>
+          </a:blip>
+          <a:srcRect l="50433"/>
+          <a:stretch/>
+        </p:blipFill>
+        <p:spPr bwMode="auto">
+          <a:xfrm rot="4230197" flipH="1">
+            <a:off x="8701876" y="65715"/>
+            <a:ext cx="2553258" cy="3653108"/>
+          </a:xfrm>
+          <a:prstGeom prst="rect">
+            <a:avLst/>
+          </a:prstGeom>
+          <a:noFill/>
+          <a:extLst>
+            <a:ext uri="{909E8E84-426E-40DD-AFC4-6F175D3DCCD1}">
+              <a14:hiddenFill xmlns:a14="http://schemas.microsoft.com/office/drawing/2010/main">
+                <a:solidFill>
+                  <a:srgbClr val="FFFFFF"/>
+                </a:solidFill>
+              </a14:hiddenFill>
+            </a:ext>
+          </a:extLst>
+        </p:spPr>
+      </p:pic>
+      <p:sp>
+        <p:nvSpPr>
+          <p:cNvPr id="3" name="TextBox 2">
+            <a:extLst>
+              <a:ext uri="{FF2B5EF4-FFF2-40B4-BE49-F238E27FC236}">
+                <a16:creationId xmlns:a16="http://schemas.microsoft.com/office/drawing/2014/main" id="{B9628755-65BA-DD6E-C74F-1673BE5799ED}"/>
+              </a:ext>
+            </a:extLst>
+          </p:cNvPr>
+          <p:cNvSpPr txBox="1"/>
+          <p:nvPr/>
+        </p:nvSpPr>
+        <p:spPr>
+          <a:xfrm>
+            <a:off x="10671142" y="6404610"/>
+            <a:ext cx="1520858" cy="461665"/>
+          </a:xfrm>
+          <a:prstGeom prst="rect">
+            <a:avLst/>
+          </a:prstGeom>
+          <a:noFill/>
+        </p:spPr>
+        <p:txBody>
+          <a:bodyPr wrap="square" rtlCol="0">
+            <a:spAutoFit/>
+          </a:bodyPr>
+          <a:lstStyle/>
+          <a:p>
+            <a:pPr algn="ctr"/>
+            <a:r>
+              <a:rPr lang="en-US" sz="2400" b="1" dirty="0">
+                <a:solidFill>
+                  <a:schemeClr val="bg1"/>
+                </a:solidFill>
+                <a:latin typeface="Montserrat" panose="00000500000000000000" pitchFamily="2" charset="0"/>
+              </a:rPr>
+              <a:t>9/10</a:t>
+            </a:r>
+          </a:p>
+        </p:txBody>
+      </p:sp>
+      <p:pic>
+        <p:nvPicPr>
+          <p:cNvPr id="5" name="Graphic 4">
+            <a:extLst>
+              <a:ext uri="{FF2B5EF4-FFF2-40B4-BE49-F238E27FC236}">
+                <a16:creationId xmlns:a16="http://schemas.microsoft.com/office/drawing/2014/main" id="{FAC18E02-D78F-5FA1-48E1-1A5CCAFFC294}"/>
+              </a:ext>
+            </a:extLst>
+          </p:cNvPr>
+          <p:cNvPicPr>
+            <a:picLocks noChangeAspect="1"/>
+          </p:cNvPicPr>
+          <p:nvPr/>
+        </p:nvPicPr>
+        <p:blipFill>
+          <a:blip r:embed="rId3">
+            <a:extLst>
+              <a:ext uri="{96DAC541-7B7A-43D3-8B79-37D633B846F1}">
+                <asvg:svgBlip xmlns:asvg="http://schemas.microsoft.com/office/drawing/2016/SVG/main" r:embed="rId4"/>
+              </a:ext>
+            </a:extLst>
+          </a:blip>
+          <a:stretch>
+            <a:fillRect/>
+          </a:stretch>
+        </p:blipFill>
+        <p:spPr>
+          <a:xfrm>
+            <a:off x="3001648" y="0"/>
+            <a:ext cx="6188703" cy="6858000"/>
+          </a:xfrm>
+          <a:prstGeom prst="rect">
+            <a:avLst/>
+          </a:prstGeom>
+        </p:spPr>
+      </p:pic>
+      <p:pic>
+        <p:nvPicPr>
+          <p:cNvPr id="10" name="Graphic 9">
+            <a:extLst>
+              <a:ext uri="{FF2B5EF4-FFF2-40B4-BE49-F238E27FC236}">
+                <a16:creationId xmlns:a16="http://schemas.microsoft.com/office/drawing/2014/main" id="{36CBB482-CF4E-95C3-3513-3A30621CEF48}"/>
+              </a:ext>
+            </a:extLst>
+          </p:cNvPr>
+          <p:cNvPicPr>
+            <a:picLocks noChangeAspect="1"/>
+          </p:cNvPicPr>
+          <p:nvPr/>
+        </p:nvPicPr>
+        <p:blipFill>
+          <a:blip r:embed="rId3">
+            <a:extLst>
+              <a:ext uri="{96DAC541-7B7A-43D3-8B79-37D633B846F1}">
+                <asvg:svgBlip xmlns:asvg="http://schemas.microsoft.com/office/drawing/2016/SVG/main" r:embed="rId4"/>
+              </a:ext>
+            </a:extLst>
+          </a:blip>
+          <a:stretch>
+            <a:fillRect/>
+          </a:stretch>
+        </p:blipFill>
+        <p:spPr>
+          <a:xfrm>
+            <a:off x="4337497" y="-1253765"/>
+            <a:ext cx="6188703" cy="6858000"/>
+          </a:xfrm>
+          <a:prstGeom prst="rect">
+            <a:avLst/>
+          </a:prstGeom>
+        </p:spPr>
+      </p:pic>
+      <p:pic>
+        <p:nvPicPr>
+          <p:cNvPr id="15" name="Picture 2" descr="High resolution abstract digital background with connected white dots and multicolor light effects on black background">
+            <a:extLst>
+              <a:ext uri="{FF2B5EF4-FFF2-40B4-BE49-F238E27FC236}">
+                <a16:creationId xmlns:a16="http://schemas.microsoft.com/office/drawing/2014/main" id="{92B5975D-9837-71DA-536E-1FE2BA54584A}"/>
+              </a:ext>
+            </a:extLst>
+          </p:cNvPr>
+          <p:cNvPicPr>
+            <a:picLocks noChangeAspect="1" noChangeArrowheads="1"/>
+          </p:cNvPicPr>
+          <p:nvPr/>
+        </p:nvPicPr>
+        <p:blipFill rotWithShape="1">
+          <a:blip r:embed="rId2">
+            <a:extLst>
+              <a:ext uri="{28A0092B-C50C-407E-A947-70E740481C1C}">
+                <a14:useLocalDpi xmlns:a14="http://schemas.microsoft.com/office/drawing/2010/main" val="0"/>
+              </a:ext>
+            </a:extLst>
+          </a:blip>
+          <a:srcRect l="50433"/>
+          <a:stretch/>
+        </p:blipFill>
+        <p:spPr bwMode="auto">
+          <a:xfrm rot="16508661" flipH="1">
+            <a:off x="830915" y="2805991"/>
+            <a:ext cx="2463336" cy="3524451"/>
+          </a:xfrm>
+          <a:prstGeom prst="rect">
+            <a:avLst/>
+          </a:prstGeom>
+          <a:noFill/>
+          <a:extLst>
+            <a:ext uri="{909E8E84-426E-40DD-AFC4-6F175D3DCCD1}">
+              <a14:hiddenFill xmlns:a14="http://schemas.microsoft.com/office/drawing/2010/main">
+                <a:solidFill>
+                  <a:srgbClr val="FFFFFF"/>
+                </a:solidFill>
+              </a14:hiddenFill>
+            </a:ext>
+          </a:extLst>
+        </p:spPr>
+      </p:pic>
+      <p:grpSp>
+        <p:nvGrpSpPr>
+          <p:cNvPr id="9" name="Group 8">
+            <a:extLst>
+              <a:ext uri="{FF2B5EF4-FFF2-40B4-BE49-F238E27FC236}">
+                <a16:creationId xmlns:a16="http://schemas.microsoft.com/office/drawing/2014/main" id="{F2C45289-90D8-241A-C63E-D81224A4354F}"/>
+              </a:ext>
+            </a:extLst>
+          </p:cNvPr>
+          <p:cNvGrpSpPr/>
+          <p:nvPr/>
+        </p:nvGrpSpPr>
+        <p:grpSpPr>
+          <a:xfrm>
+            <a:off x="805990" y="1352510"/>
+            <a:ext cx="10580017" cy="3323987"/>
+            <a:chOff x="805990" y="1523910"/>
+            <a:chExt cx="10580017" cy="3323987"/>
+          </a:xfrm>
+        </p:grpSpPr>
+        <p:sp>
+          <p:nvSpPr>
+            <p:cNvPr id="8" name="TextBox 7">
+              <a:extLst>
+                <a:ext uri="{FF2B5EF4-FFF2-40B4-BE49-F238E27FC236}">
+                  <a16:creationId xmlns:a16="http://schemas.microsoft.com/office/drawing/2014/main" id="{BC482FBF-9716-CA59-7608-C317C4C5AF8C}"/>
+                </a:ext>
+              </a:extLst>
+            </p:cNvPr>
+            <p:cNvSpPr txBox="1"/>
+            <p:nvPr/>
+          </p:nvSpPr>
+          <p:spPr>
+            <a:xfrm>
+              <a:off x="805990" y="1523910"/>
+              <a:ext cx="10580017" cy="1200329"/>
+            </a:xfrm>
+            <a:prstGeom prst="rect">
+              <a:avLst/>
+            </a:prstGeom>
+            <a:noFill/>
+          </p:spPr>
+          <p:txBody>
+            <a:bodyPr wrap="square" rtlCol="0">
+              <a:spAutoFit/>
+            </a:bodyPr>
+            <a:lstStyle/>
+            <a:p>
+              <a:pPr algn="ctr"/>
+              <a:r>
+                <a:rPr lang="bg-BG" sz="7200" b="1" dirty="0">
+                  <a:solidFill>
+                    <a:schemeClr val="bg1"/>
+                  </a:solidFill>
+                  <a:latin typeface="Montserrat" panose="00000500000000000000" pitchFamily="2" charset="0"/>
+                </a:rPr>
+                <a:t>ДЕМОНСТРАЦИЯ</a:t>
+              </a:r>
+              <a:endParaRPr lang="en-US" sz="7200" b="1" dirty="0">
+                <a:solidFill>
+                  <a:schemeClr val="bg1"/>
+                </a:solidFill>
+                <a:latin typeface="Montserrat" panose="00000500000000000000" pitchFamily="2" charset="0"/>
+              </a:endParaRPr>
+            </a:p>
+          </p:txBody>
+        </p:sp>
+        <p:sp>
+          <p:nvSpPr>
+            <p:cNvPr id="2" name="TextBox 1">
+              <a:extLst>
+                <a:ext uri="{FF2B5EF4-FFF2-40B4-BE49-F238E27FC236}">
+                  <a16:creationId xmlns:a16="http://schemas.microsoft.com/office/drawing/2014/main" id="{EE283427-CC39-D6B5-4C8D-FC9E0733A5B2}"/>
+                </a:ext>
+              </a:extLst>
+            </p:cNvPr>
+            <p:cNvSpPr txBox="1"/>
+            <p:nvPr/>
+          </p:nvSpPr>
+          <p:spPr>
+            <a:xfrm>
+              <a:off x="1247775" y="2724239"/>
+              <a:ext cx="9278425" cy="2123658"/>
+            </a:xfrm>
+            <a:prstGeom prst="rect">
+              <a:avLst/>
+            </a:prstGeom>
+            <a:noFill/>
+          </p:spPr>
+          <p:txBody>
+            <a:bodyPr wrap="square" rtlCol="0">
+              <a:spAutoFit/>
+            </a:bodyPr>
+            <a:lstStyle/>
+            <a:p>
+              <a:pPr marL="914400" lvl="1" indent="-457200">
+                <a:buClr>
+                  <a:schemeClr val="bg1"/>
+                </a:buClr>
+                <a:buSzPct val="120000"/>
+                <a:buFont typeface="System Font Regular"/>
+                <a:buChar char="→"/>
+              </a:pPr>
+              <a:r>
+                <a:rPr lang="bg-BG" sz="2400" i="0" dirty="0">
+                  <a:solidFill>
+                    <a:schemeClr val="bg1"/>
+                  </a:solidFill>
+                  <a:effectLst/>
+                  <a:latin typeface="Montserrat" panose="00000500000000000000" pitchFamily="2" charset="0"/>
+                </a:rPr>
+                <a:t>Разпознаване на нарисувани цифри</a:t>
+              </a:r>
+              <a:endParaRPr lang="en-US" sz="2400" i="0" dirty="0">
+                <a:solidFill>
+                  <a:schemeClr val="bg1"/>
+                </a:solidFill>
+                <a:effectLst/>
+                <a:latin typeface="Montserrat" panose="00000500000000000000" pitchFamily="2" charset="0"/>
+              </a:endParaRPr>
+            </a:p>
+            <a:p>
+              <a:pPr marL="914400" lvl="1" indent="-457200">
+                <a:buClr>
+                  <a:schemeClr val="bg1"/>
+                </a:buClr>
+                <a:buSzPct val="120000"/>
+                <a:buFont typeface="System Font Regular"/>
+                <a:buChar char="→"/>
+              </a:pPr>
+              <a:endParaRPr lang="en-US" sz="1200" i="0" dirty="0">
+                <a:solidFill>
+                  <a:schemeClr val="bg1"/>
+                </a:solidFill>
+                <a:effectLst/>
+                <a:latin typeface="Montserrat" panose="00000500000000000000" pitchFamily="2" charset="0"/>
+              </a:endParaRPr>
+            </a:p>
+            <a:p>
+              <a:pPr marL="914400" lvl="1" indent="-457200">
+                <a:buClr>
+                  <a:schemeClr val="bg1"/>
+                </a:buClr>
+                <a:buSzPct val="120000"/>
+                <a:buFont typeface="System Font Regular"/>
+                <a:buChar char="→"/>
+              </a:pPr>
+              <a:r>
+                <a:rPr lang="bg-BG" sz="2400" dirty="0">
+                  <a:solidFill>
+                    <a:schemeClr val="bg1"/>
+                  </a:solidFill>
+                  <a:latin typeface="Montserrat" panose="00000500000000000000" pitchFamily="2" charset="0"/>
+                </a:rPr>
+                <a:t>Визуализация на невронна мрежа</a:t>
+              </a:r>
+              <a:endParaRPr lang="en-US" sz="2400" dirty="0">
+                <a:solidFill>
+                  <a:schemeClr val="bg1"/>
+                </a:solidFill>
+                <a:latin typeface="Montserrat" panose="00000500000000000000" pitchFamily="2" charset="0"/>
+              </a:endParaRPr>
+            </a:p>
+            <a:p>
+              <a:pPr marL="914400" lvl="1" indent="-457200">
+                <a:buClr>
+                  <a:schemeClr val="bg1"/>
+                </a:buClr>
+                <a:buSzPct val="120000"/>
+                <a:buFont typeface="System Font Regular"/>
+                <a:buChar char="→"/>
+              </a:pPr>
+              <a:endParaRPr lang="bg-BG" sz="1200" dirty="0">
+                <a:solidFill>
+                  <a:schemeClr val="bg1"/>
+                </a:solidFill>
+                <a:latin typeface="Montserrat" panose="00000500000000000000" pitchFamily="2" charset="0"/>
+              </a:endParaRPr>
+            </a:p>
+            <a:p>
+              <a:pPr marL="914400" lvl="1" indent="-457200">
+                <a:buClr>
+                  <a:schemeClr val="bg1"/>
+                </a:buClr>
+                <a:buSzPct val="120000"/>
+                <a:buFont typeface="System Font Regular"/>
+                <a:buChar char="→"/>
+              </a:pPr>
+              <a:r>
+                <a:rPr lang="bg-BG" sz="2400" dirty="0">
+                  <a:solidFill>
+                    <a:schemeClr val="bg1"/>
+                  </a:solidFill>
+                  <a:latin typeface="Montserrat" panose="00000500000000000000" pitchFamily="2" charset="0"/>
+                </a:rPr>
+                <a:t>Универсално разпознаване на символи  </a:t>
+              </a:r>
+              <a:endParaRPr lang="en-US" sz="2400" dirty="0">
+                <a:solidFill>
+                  <a:schemeClr val="bg1"/>
+                </a:solidFill>
+                <a:latin typeface="Montserrat" panose="00000500000000000000" pitchFamily="2" charset="0"/>
+              </a:endParaRPr>
+            </a:p>
+            <a:p>
+              <a:pPr marL="914400" lvl="1" indent="-457200">
+                <a:buClr>
+                  <a:schemeClr val="bg1"/>
+                </a:buClr>
+                <a:buSzPct val="120000"/>
+                <a:buFont typeface="System Font Regular"/>
+                <a:buChar char="→"/>
+              </a:pPr>
+              <a:endParaRPr lang="en-US" sz="1200" dirty="0">
+                <a:solidFill>
+                  <a:schemeClr val="bg1"/>
+                </a:solidFill>
+                <a:latin typeface="Montserrat" panose="00000500000000000000" pitchFamily="2" charset="0"/>
+              </a:endParaRPr>
+            </a:p>
+            <a:p>
+              <a:pPr marL="914400" lvl="1" indent="-457200">
+                <a:buClr>
+                  <a:schemeClr val="bg1"/>
+                </a:buClr>
+                <a:buSzPct val="120000"/>
+                <a:buFont typeface="System Font Regular"/>
+                <a:buChar char="→"/>
+              </a:pPr>
+              <a:r>
+                <a:rPr lang="bg-BG" sz="2400" dirty="0">
+                  <a:solidFill>
+                    <a:schemeClr val="bg1"/>
+                  </a:solidFill>
+                  <a:latin typeface="Montserrat" panose="00000500000000000000" pitchFamily="2" charset="0"/>
+                </a:rPr>
+                <a:t>Платформа за решаване на квадратни уравнения</a:t>
+              </a:r>
+              <a:endParaRPr lang="en-US" sz="2400" dirty="0">
+                <a:solidFill>
+                  <a:schemeClr val="bg1"/>
+                </a:solidFill>
+                <a:latin typeface="Montserrat" panose="00000500000000000000" pitchFamily="2" charset="0"/>
+              </a:endParaRPr>
+            </a:p>
+          </p:txBody>
+        </p:sp>
+      </p:grpSp>
+      <p:pic>
+        <p:nvPicPr>
+          <p:cNvPr id="4" name="Picture 3" descr="A blue and green connected circles&#10;&#10;AI-generated content may be incorrect.">
+            <a:extLst>
+              <a:ext uri="{FF2B5EF4-FFF2-40B4-BE49-F238E27FC236}">
+                <a16:creationId xmlns:a16="http://schemas.microsoft.com/office/drawing/2014/main" id="{8959D21F-C9F9-1924-0816-344796C5A6E8}"/>
+              </a:ext>
+            </a:extLst>
+          </p:cNvPr>
+          <p:cNvPicPr>
+            <a:picLocks noChangeAspect="1"/>
+          </p:cNvPicPr>
+          <p:nvPr/>
+        </p:nvPicPr>
+        <p:blipFill>
+          <a:blip r:embed="rId5">
+            <a:extLst>
+              <a:ext uri="{28A0092B-C50C-407E-A947-70E740481C1C}">
+                <a14:useLocalDpi xmlns:a14="http://schemas.microsoft.com/office/drawing/2010/main" val="0"/>
+              </a:ext>
+            </a:extLst>
+          </a:blip>
+          <a:stretch>
+            <a:fillRect/>
+          </a:stretch>
+        </p:blipFill>
+        <p:spPr>
+          <a:xfrm>
+            <a:off x="355575" y="338896"/>
+            <a:ext cx="1243757" cy="937506"/>
+          </a:xfrm>
+          <a:prstGeom prst="rect">
+            <a:avLst/>
+          </a:prstGeom>
+        </p:spPr>
+      </p:pic>
+    </p:spTree>
+    <p:extLst>
+      <p:ext uri="{BB962C8B-B14F-4D97-AF65-F5344CB8AC3E}">
+        <p14:creationId xmlns:p14="http://schemas.microsoft.com/office/powerpoint/2010/main" val="2296167999"/>
+      </p:ext>
+    </p:extLst>
+  </p:cSld>
+  <p:clrMapOvr>
+    <a:masterClrMapping/>
+  </p:clrMapOvr>
+</p:sld>
+</file>
+
+<file path=ppt/slides/slide11.xml><?xml version="1.0" encoding="utf-8"?>
+<p:sld xmlns:a="http://schemas.openxmlformats.org/drawingml/2006/main" xmlns:r="http://schemas.openxmlformats.org/officeDocument/2006/relationships" xmlns:p="http://schemas.openxmlformats.org/presentationml/2006/main">
+  <p:cSld>
+    <p:spTree>
+      <p:nvGrpSpPr>
+        <p:cNvPr id="1" name="">
+          <a:extLst>
+            <a:ext uri="{FF2B5EF4-FFF2-40B4-BE49-F238E27FC236}">
               <a16:creationId xmlns:a16="http://schemas.microsoft.com/office/drawing/2014/main" id="{8EDCF3F9-E788-926E-F039-8C2A7F95C5CA}"/>
             </a:ext>
           </a:extLst>
@@ -2266,7 +2790,7 @@
                 </a:solidFill>
                 <a:latin typeface="Montserrat" panose="00000500000000000000" pitchFamily="2" charset="0"/>
               </a:rPr>
-              <a:t>9/10</a:t>
+              <a:t>10/10</a:t>
             </a:r>
           </a:p>
         </p:txBody>
@@ -2489,7 +3013,7 @@
 </p:sld>
 </file>
 
-<file path=ppt/slides/slide11.xml><?xml version="1.0" encoding="utf-8"?>
+<file path=ppt/slides/slide12.xml><?xml version="1.0" encoding="utf-8"?>
 <p:sld xmlns:a="http://schemas.openxmlformats.org/drawingml/2006/main" xmlns:r="http://schemas.openxmlformats.org/officeDocument/2006/relationships" xmlns:p="http://schemas.openxmlformats.org/presentationml/2006/main" showMasterSp="0">
   <p:cSld>
     <p:bg>
@@ -7097,6 +7621,921 @@
         <p:cNvPr id="1" name="">
           <a:extLst>
             <a:ext uri="{FF2B5EF4-FFF2-40B4-BE49-F238E27FC236}">
+              <a16:creationId xmlns:a16="http://schemas.microsoft.com/office/drawing/2014/main" id="{FBCDEDE8-5D88-7016-9DC1-3F14BFA62CD8}"/>
+            </a:ext>
+          </a:extLst>
+        </p:cNvPr>
+        <p:cNvGrpSpPr/>
+        <p:nvPr/>
+      </p:nvGrpSpPr>
+      <p:grpSpPr>
+        <a:xfrm>
+          <a:off x="0" y="0"/>
+          <a:ext cx="0" cy="0"/>
+          <a:chOff x="0" y="0"/>
+          <a:chExt cx="0" cy="0"/>
+        </a:xfrm>
+      </p:grpSpPr>
+      <p:sp>
+        <p:nvSpPr>
+          <p:cNvPr id="8" name="TextBox 7">
+            <a:extLst>
+              <a:ext uri="{FF2B5EF4-FFF2-40B4-BE49-F238E27FC236}">
+                <a16:creationId xmlns:a16="http://schemas.microsoft.com/office/drawing/2014/main" id="{9A8B37F7-450A-A15D-167C-F93DEAD340D3}"/>
+              </a:ext>
+            </a:extLst>
+          </p:cNvPr>
+          <p:cNvSpPr txBox="1"/>
+          <p:nvPr/>
+        </p:nvSpPr>
+        <p:spPr>
+          <a:xfrm>
+            <a:off x="91124" y="76732"/>
+            <a:ext cx="10580017" cy="707886"/>
+          </a:xfrm>
+          <a:prstGeom prst="rect">
+            <a:avLst/>
+          </a:prstGeom>
+          <a:noFill/>
+        </p:spPr>
+        <p:txBody>
+          <a:bodyPr wrap="square" rtlCol="0">
+            <a:spAutoFit/>
+          </a:bodyPr>
+          <a:lstStyle/>
+          <a:p>
+            <a:r>
+              <a:rPr lang="bg-BG" sz="4000" b="1" dirty="0">
+                <a:solidFill>
+                  <a:schemeClr val="bg1"/>
+                </a:solidFill>
+                <a:latin typeface="Montserrat" panose="00000500000000000000" pitchFamily="2" charset="0"/>
+              </a:rPr>
+              <a:t>Активна разработка &amp; Новости</a:t>
+            </a:r>
+            <a:endParaRPr lang="en-US" sz="4000" b="1" dirty="0">
+              <a:solidFill>
+                <a:schemeClr val="bg1"/>
+              </a:solidFill>
+              <a:latin typeface="Montserrat" panose="00000500000000000000" pitchFamily="2" charset="0"/>
+            </a:endParaRPr>
+          </a:p>
+        </p:txBody>
+      </p:sp>
+      <p:sp>
+        <p:nvSpPr>
+          <p:cNvPr id="3" name="TextBox 2">
+            <a:extLst>
+              <a:ext uri="{FF2B5EF4-FFF2-40B4-BE49-F238E27FC236}">
+                <a16:creationId xmlns:a16="http://schemas.microsoft.com/office/drawing/2014/main" id="{4BEDBC06-7900-40B9-C609-4AA93BBF83B9}"/>
+              </a:ext>
+            </a:extLst>
+          </p:cNvPr>
+          <p:cNvSpPr txBox="1"/>
+          <p:nvPr/>
+        </p:nvSpPr>
+        <p:spPr>
+          <a:xfrm>
+            <a:off x="10671142" y="6404610"/>
+            <a:ext cx="1520858" cy="461665"/>
+          </a:xfrm>
+          <a:prstGeom prst="rect">
+            <a:avLst/>
+          </a:prstGeom>
+          <a:noFill/>
+        </p:spPr>
+        <p:txBody>
+          <a:bodyPr wrap="square" rtlCol="0">
+            <a:spAutoFit/>
+          </a:bodyPr>
+          <a:lstStyle/>
+          <a:p>
+            <a:pPr algn="ctr"/>
+            <a:r>
+              <a:rPr lang="en-US" sz="2400" b="1" dirty="0">
+                <a:solidFill>
+                  <a:schemeClr val="bg1"/>
+                </a:solidFill>
+                <a:latin typeface="Montserrat" panose="00000500000000000000" pitchFamily="2" charset="0"/>
+              </a:rPr>
+              <a:t>7/10</a:t>
+            </a:r>
+          </a:p>
+        </p:txBody>
+      </p:sp>
+      <p:cxnSp>
+        <p:nvCxnSpPr>
+          <p:cNvPr id="6" name="Straight Connector 5">
+            <a:extLst>
+              <a:ext uri="{FF2B5EF4-FFF2-40B4-BE49-F238E27FC236}">
+                <a16:creationId xmlns:a16="http://schemas.microsoft.com/office/drawing/2014/main" id="{6C36963F-E986-C9D4-E1E9-81E4F025527B}"/>
+              </a:ext>
+            </a:extLst>
+          </p:cNvPr>
+          <p:cNvCxnSpPr/>
+          <p:nvPr/>
+        </p:nvCxnSpPr>
+        <p:spPr>
+          <a:xfrm>
+            <a:off x="0" y="869783"/>
+            <a:ext cx="12192000" cy="0"/>
+          </a:xfrm>
+          <a:prstGeom prst="line">
+            <a:avLst/>
+          </a:prstGeom>
+          <a:ln w="31750">
+            <a:solidFill>
+              <a:schemeClr val="bg1">
+                <a:alpha val="25000"/>
+              </a:schemeClr>
+            </a:solidFill>
+          </a:ln>
+        </p:spPr>
+        <p:style>
+          <a:lnRef idx="2">
+            <a:schemeClr val="accent1"/>
+          </a:lnRef>
+          <a:fillRef idx="0">
+            <a:schemeClr val="accent1"/>
+          </a:fillRef>
+          <a:effectRef idx="1">
+            <a:schemeClr val="accent1"/>
+          </a:effectRef>
+          <a:fontRef idx="minor">
+            <a:schemeClr val="tx1"/>
+          </a:fontRef>
+        </p:style>
+      </p:cxnSp>
+      <p:pic>
+        <p:nvPicPr>
+          <p:cNvPr id="5" name="Graphic 4">
+            <a:extLst>
+              <a:ext uri="{FF2B5EF4-FFF2-40B4-BE49-F238E27FC236}">
+                <a16:creationId xmlns:a16="http://schemas.microsoft.com/office/drawing/2014/main" id="{3A1BFE1D-94D4-2D2F-44BE-41E10A13DF2F}"/>
+              </a:ext>
+            </a:extLst>
+          </p:cNvPr>
+          <p:cNvPicPr>
+            <a:picLocks noChangeAspect="1"/>
+          </p:cNvPicPr>
+          <p:nvPr/>
+        </p:nvPicPr>
+        <p:blipFill>
+          <a:blip r:embed="rId2">
+            <a:extLst>
+              <a:ext uri="{96DAC541-7B7A-43D3-8B79-37D633B846F1}">
+                <asvg:svgBlip xmlns:asvg="http://schemas.microsoft.com/office/drawing/2016/SVG/main" r:embed="rId3"/>
+              </a:ext>
+            </a:extLst>
+          </a:blip>
+          <a:stretch>
+            <a:fillRect/>
+          </a:stretch>
+        </p:blipFill>
+        <p:spPr>
+          <a:xfrm>
+            <a:off x="3001648" y="0"/>
+            <a:ext cx="6188703" cy="6858000"/>
+          </a:xfrm>
+          <a:prstGeom prst="rect">
+            <a:avLst/>
+          </a:prstGeom>
+        </p:spPr>
+      </p:pic>
+      <p:pic>
+        <p:nvPicPr>
+          <p:cNvPr id="10" name="Graphic 9">
+            <a:extLst>
+              <a:ext uri="{FF2B5EF4-FFF2-40B4-BE49-F238E27FC236}">
+                <a16:creationId xmlns:a16="http://schemas.microsoft.com/office/drawing/2014/main" id="{792D045C-B586-D21E-7E09-749CE6B4F9D7}"/>
+              </a:ext>
+            </a:extLst>
+          </p:cNvPr>
+          <p:cNvPicPr>
+            <a:picLocks noChangeAspect="1"/>
+          </p:cNvPicPr>
+          <p:nvPr/>
+        </p:nvPicPr>
+        <p:blipFill>
+          <a:blip r:embed="rId2">
+            <a:extLst>
+              <a:ext uri="{96DAC541-7B7A-43D3-8B79-37D633B846F1}">
+                <asvg:svgBlip xmlns:asvg="http://schemas.microsoft.com/office/drawing/2016/SVG/main" r:embed="rId3"/>
+              </a:ext>
+            </a:extLst>
+          </a:blip>
+          <a:stretch>
+            <a:fillRect/>
+          </a:stretch>
+        </p:blipFill>
+        <p:spPr>
+          <a:xfrm>
+            <a:off x="4337497" y="-1253765"/>
+            <a:ext cx="6188703" cy="6858000"/>
+          </a:xfrm>
+          <a:prstGeom prst="rect">
+            <a:avLst/>
+          </a:prstGeom>
+        </p:spPr>
+      </p:pic>
+      <p:grpSp>
+        <p:nvGrpSpPr>
+          <p:cNvPr id="11" name="Group 10">
+            <a:extLst>
+              <a:ext uri="{FF2B5EF4-FFF2-40B4-BE49-F238E27FC236}">
+                <a16:creationId xmlns:a16="http://schemas.microsoft.com/office/drawing/2014/main" id="{18D24411-4868-1E5E-C7AD-12E25C1C9AB5}"/>
+              </a:ext>
+            </a:extLst>
+          </p:cNvPr>
+          <p:cNvGrpSpPr/>
+          <p:nvPr/>
+        </p:nvGrpSpPr>
+        <p:grpSpPr>
+          <a:xfrm>
+            <a:off x="-336886" y="1029037"/>
+            <a:ext cx="7464208" cy="5170646"/>
+            <a:chOff x="-303012" y="1375039"/>
+            <a:chExt cx="7464208" cy="5170646"/>
+          </a:xfrm>
+        </p:grpSpPr>
+        <p:sp>
+          <p:nvSpPr>
+            <p:cNvPr id="7" name="TextBox 6">
+              <a:extLst>
+                <a:ext uri="{FF2B5EF4-FFF2-40B4-BE49-F238E27FC236}">
+                  <a16:creationId xmlns:a16="http://schemas.microsoft.com/office/drawing/2014/main" id="{9AFE987D-B2BA-B905-A07A-76E4DA016509}"/>
+                </a:ext>
+              </a:extLst>
+            </p:cNvPr>
+            <p:cNvSpPr txBox="1"/>
+            <p:nvPr/>
+          </p:nvSpPr>
+          <p:spPr>
+            <a:xfrm>
+              <a:off x="-303012" y="1375039"/>
+              <a:ext cx="7464208" cy="5170646"/>
+            </a:xfrm>
+            <a:prstGeom prst="rect">
+              <a:avLst/>
+            </a:prstGeom>
+            <a:noFill/>
+          </p:spPr>
+          <p:txBody>
+            <a:bodyPr wrap="square" rtlCol="0">
+              <a:spAutoFit/>
+            </a:bodyPr>
+            <a:lstStyle/>
+            <a:p>
+              <a:pPr marL="914400" lvl="1" indent="-457200">
+                <a:buClr>
+                  <a:schemeClr val="bg1"/>
+                </a:buClr>
+                <a:buSzPct val="120000"/>
+                <a:buFont typeface="System Font Regular"/>
+                <a:buChar char="→"/>
+              </a:pPr>
+              <a:r>
+                <a:rPr lang="bg-BG" sz="2400" b="1" dirty="0">
+                  <a:solidFill>
+                    <a:schemeClr val="bg1"/>
+                  </a:solidFill>
+                  <a:latin typeface="Montserrat" panose="00000500000000000000" pitchFamily="2" charset="0"/>
+                </a:rPr>
+                <a:t>Методи за инициализация на теглата:</a:t>
+              </a:r>
+            </a:p>
+            <a:p>
+              <a:pPr lvl="1" algn="ctr">
+                <a:buClr>
+                  <a:schemeClr val="bg1"/>
+                </a:buClr>
+                <a:buSzPct val="120000"/>
+              </a:pPr>
+              <a:r>
+                <a:rPr lang="bg-BG" sz="2000" dirty="0">
+                  <a:solidFill>
+                    <a:schemeClr val="bg1"/>
+                  </a:solidFill>
+                  <a:latin typeface="Montserrat" panose="00000500000000000000" pitchFamily="2" charset="0"/>
+                </a:rPr>
+                <a:t>(</a:t>
+              </a:r>
+              <a:r>
+                <a:rPr lang="en-US" sz="2000" dirty="0">
+                  <a:solidFill>
+                    <a:schemeClr val="bg1"/>
+                  </a:solidFill>
+                  <a:latin typeface="Montserrat" panose="00000500000000000000" pitchFamily="2" charset="0"/>
+                </a:rPr>
+                <a:t>He, Xavier, Orthogonal, Uniform</a:t>
+              </a:r>
+              <a:r>
+                <a:rPr lang="bg-BG" sz="2000" dirty="0">
+                  <a:solidFill>
+                    <a:schemeClr val="bg1"/>
+                  </a:solidFill>
+                  <a:latin typeface="Montserrat" panose="00000500000000000000" pitchFamily="2" charset="0"/>
+                </a:rPr>
+                <a:t>)</a:t>
+              </a:r>
+              <a:endParaRPr lang="bg-BG" sz="2000" dirty="0">
+                <a:solidFill>
+                  <a:schemeClr val="bg1"/>
+                </a:solidFill>
+                <a:effectLst/>
+                <a:latin typeface="Montserrat" panose="00000500000000000000" pitchFamily="2" charset="0"/>
+              </a:endParaRPr>
+            </a:p>
+            <a:p>
+              <a:pPr marL="914400" lvl="1" indent="-457200">
+                <a:buClr>
+                  <a:schemeClr val="bg1"/>
+                </a:buClr>
+                <a:buSzPct val="120000"/>
+                <a:buFont typeface="System Font Regular"/>
+                <a:buChar char="→"/>
+              </a:pPr>
+              <a:endParaRPr lang="en-US" sz="2400" i="0" dirty="0">
+                <a:solidFill>
+                  <a:schemeClr val="bg1"/>
+                </a:solidFill>
+                <a:effectLst/>
+                <a:latin typeface="Montserrat" panose="00000500000000000000" pitchFamily="2" charset="0"/>
+              </a:endParaRPr>
+            </a:p>
+            <a:p>
+              <a:pPr marL="914400" lvl="1" indent="-457200">
+                <a:buClr>
+                  <a:schemeClr val="bg1"/>
+                </a:buClr>
+                <a:buSzPct val="120000"/>
+                <a:buFont typeface="System Font Regular"/>
+                <a:buChar char="→"/>
+              </a:pPr>
+              <a:r>
+                <a:rPr lang="en-US" sz="2400" b="1" dirty="0">
+                  <a:solidFill>
+                    <a:schemeClr val="bg1"/>
+                  </a:solidFill>
+                  <a:latin typeface="Montserrat" panose="00000500000000000000" pitchFamily="2" charset="0"/>
+                </a:rPr>
+                <a:t>Advanced learning rate schedulers</a:t>
+              </a:r>
+              <a:r>
+                <a:rPr lang="en-US" sz="2400" i="0" dirty="0">
+                  <a:solidFill>
+                    <a:schemeClr val="bg1"/>
+                  </a:solidFill>
+                  <a:effectLst/>
+                  <a:latin typeface="Montserrat" panose="00000500000000000000" pitchFamily="2" charset="0"/>
+                </a:rPr>
+                <a:t>:</a:t>
+              </a:r>
+              <a:endParaRPr lang="bg-BG" sz="2400" i="0" dirty="0">
+                <a:solidFill>
+                  <a:schemeClr val="bg1"/>
+                </a:solidFill>
+                <a:effectLst/>
+                <a:latin typeface="Montserrat" panose="00000500000000000000" pitchFamily="2" charset="0"/>
+              </a:endParaRPr>
+            </a:p>
+            <a:p>
+              <a:pPr lvl="1" algn="ctr">
+                <a:buClr>
+                  <a:schemeClr val="bg1"/>
+                </a:buClr>
+                <a:buSzPct val="120000"/>
+              </a:pPr>
+              <a:endParaRPr lang="bg-BG" sz="800" dirty="0">
+                <a:solidFill>
+                  <a:schemeClr val="bg1"/>
+                </a:solidFill>
+                <a:latin typeface="Montserrat" panose="00000500000000000000" pitchFamily="2" charset="0"/>
+              </a:endParaRPr>
+            </a:p>
+            <a:p>
+              <a:pPr lvl="1" algn="ctr">
+                <a:buClr>
+                  <a:schemeClr val="bg1"/>
+                </a:buClr>
+                <a:buSzPct val="120000"/>
+              </a:pPr>
+              <a:r>
+                <a:rPr lang="en-US" sz="2000" noProof="0" dirty="0">
+                  <a:solidFill>
+                    <a:schemeClr val="bg1"/>
+                  </a:solidFill>
+                  <a:latin typeface="Montserrat" panose="00000500000000000000" pitchFamily="2" charset="0"/>
+                </a:rPr>
+                <a:t>Step, Exponential, CosineAnnealing, ReduceLROnPlateau, OneCycleLR</a:t>
+              </a:r>
+            </a:p>
+            <a:p>
+              <a:pPr lvl="1" algn="ctr">
+                <a:buClr>
+                  <a:schemeClr val="bg1"/>
+                </a:buClr>
+                <a:buSzPct val="120000"/>
+              </a:pPr>
+              <a:endParaRPr lang="en-US" sz="2200" i="0" dirty="0">
+                <a:solidFill>
+                  <a:schemeClr val="bg1"/>
+                </a:solidFill>
+                <a:effectLst/>
+                <a:latin typeface="Montserrat" panose="00000500000000000000" pitchFamily="2" charset="0"/>
+              </a:endParaRPr>
+            </a:p>
+            <a:p>
+              <a:pPr marL="914400" lvl="1" indent="-457200">
+                <a:buClr>
+                  <a:schemeClr val="bg1"/>
+                </a:buClr>
+                <a:buSzPct val="120000"/>
+                <a:buFont typeface="System Font Regular"/>
+                <a:buChar char="→"/>
+              </a:pPr>
+              <a:r>
+                <a:rPr lang="en-US" sz="2400" b="1" dirty="0">
+                  <a:solidFill>
+                    <a:schemeClr val="bg1"/>
+                  </a:solidFill>
+                  <a:latin typeface="Montserrat" panose="00000500000000000000" pitchFamily="2" charset="0"/>
+                </a:rPr>
+                <a:t>Gradient clipping</a:t>
+              </a:r>
+            </a:p>
+            <a:p>
+              <a:pPr marL="914400" lvl="1" indent="-457200">
+                <a:buClr>
+                  <a:schemeClr val="bg1"/>
+                </a:buClr>
+                <a:buSzPct val="120000"/>
+                <a:buFont typeface="System Font Regular"/>
+                <a:buChar char="→"/>
+              </a:pPr>
+              <a:endParaRPr lang="en-US" sz="2400" b="1" i="0" dirty="0">
+                <a:solidFill>
+                  <a:schemeClr val="bg1"/>
+                </a:solidFill>
+                <a:effectLst/>
+                <a:latin typeface="Montserrat" panose="00000500000000000000" pitchFamily="2" charset="0"/>
+              </a:endParaRPr>
+            </a:p>
+            <a:p>
+              <a:pPr marL="914400" lvl="1" indent="-457200">
+                <a:buClr>
+                  <a:schemeClr val="bg1"/>
+                </a:buClr>
+                <a:buSzPct val="120000"/>
+                <a:buFont typeface="System Font Regular"/>
+                <a:buChar char="→"/>
+              </a:pPr>
+              <a:r>
+                <a:rPr lang="bg-BG" sz="2400" dirty="0">
+                  <a:solidFill>
+                    <a:schemeClr val="bg1"/>
+                  </a:solidFill>
+                  <a:latin typeface="Montserrat" panose="00000500000000000000" pitchFamily="2" charset="0"/>
+                </a:rPr>
+                <a:t>Нова и подобрена </a:t>
+              </a:r>
+              <a:r>
+                <a:rPr lang="en-US" sz="2400" dirty="0">
+                  <a:solidFill>
+                    <a:schemeClr val="bg1"/>
+                  </a:solidFill>
+                  <a:latin typeface="Montserrat" panose="00000500000000000000" pitchFamily="2" charset="0"/>
+                </a:rPr>
+                <a:t>web </a:t>
+              </a:r>
+              <a:r>
+                <a:rPr lang="bg-BG" sz="2400" dirty="0">
+                  <a:solidFill>
+                    <a:schemeClr val="bg1"/>
+                  </a:solidFill>
+                  <a:latin typeface="Montserrat" panose="00000500000000000000" pitchFamily="2" charset="0"/>
+                </a:rPr>
+                <a:t>версия на </a:t>
+              </a:r>
+              <a:r>
+                <a:rPr lang="en-US" sz="2400" dirty="0">
+                  <a:solidFill>
+                    <a:schemeClr val="bg1"/>
+                  </a:solidFill>
+                  <a:latin typeface="Montserrat" panose="00000500000000000000" pitchFamily="2" charset="0"/>
+                </a:rPr>
+                <a:t>Universal Character Recognizer</a:t>
+              </a:r>
+            </a:p>
+            <a:p>
+              <a:pPr marL="914400" lvl="1" indent="-457200">
+                <a:buClr>
+                  <a:schemeClr val="bg1"/>
+                </a:buClr>
+                <a:buSzPct val="120000"/>
+                <a:buFont typeface="System Font Regular"/>
+                <a:buChar char="→"/>
+              </a:pPr>
+              <a:endParaRPr lang="en-US" sz="2400" dirty="0">
+                <a:solidFill>
+                  <a:schemeClr val="bg1"/>
+                </a:solidFill>
+                <a:latin typeface="Montserrat" panose="00000500000000000000" pitchFamily="2" charset="0"/>
+              </a:endParaRPr>
+            </a:p>
+            <a:p>
+              <a:pPr marL="914400" lvl="1" indent="-457200">
+                <a:buClr>
+                  <a:schemeClr val="bg1"/>
+                </a:buClr>
+                <a:buSzPct val="120000"/>
+                <a:buFont typeface="System Font Regular"/>
+                <a:buChar char="→"/>
+              </a:pPr>
+              <a:r>
+                <a:rPr lang="bg-BG" sz="2400" dirty="0">
+                  <a:solidFill>
+                    <a:schemeClr val="bg1"/>
+                  </a:solidFill>
+                  <a:latin typeface="Montserrat" panose="00000500000000000000" pitchFamily="2" charset="0"/>
+                </a:rPr>
+                <a:t>Нов алгоритъм за генериране на</a:t>
+              </a:r>
+              <a:r>
+                <a:rPr lang="en-US" sz="2400" dirty="0">
+                  <a:solidFill>
+                    <a:schemeClr val="bg1"/>
+                  </a:solidFill>
+                  <a:latin typeface="Montserrat" panose="00000500000000000000" pitchFamily="2" charset="0"/>
+                </a:rPr>
+                <a:t> </a:t>
+              </a:r>
+              <a:r>
+                <a:rPr lang="bg-BG" sz="2400" dirty="0">
+                  <a:solidFill>
+                    <a:schemeClr val="bg1"/>
+                  </a:solidFill>
+                  <a:latin typeface="Montserrat" panose="00000500000000000000" pitchFamily="2" charset="0"/>
+                </a:rPr>
+                <a:t>училищни квадратни уравнени</a:t>
+              </a:r>
+              <a:endParaRPr lang="en-US" sz="2400" dirty="0">
+                <a:solidFill>
+                  <a:schemeClr val="bg1"/>
+                </a:solidFill>
+                <a:latin typeface="Montserrat" panose="00000500000000000000" pitchFamily="2" charset="0"/>
+              </a:endParaRPr>
+            </a:p>
+          </p:txBody>
+        </p:sp>
+        <p:sp>
+          <p:nvSpPr>
+            <p:cNvPr id="4" name="TextBox 3">
+              <a:extLst>
+                <a:ext uri="{FF2B5EF4-FFF2-40B4-BE49-F238E27FC236}">
+                  <a16:creationId xmlns:a16="http://schemas.microsoft.com/office/drawing/2014/main" id="{81448EDE-8355-C3E8-EFD0-B644B7DD0DA8}"/>
+                </a:ext>
+              </a:extLst>
+            </p:cNvPr>
+            <p:cNvSpPr txBox="1"/>
+            <p:nvPr/>
+          </p:nvSpPr>
+          <p:spPr>
+            <a:xfrm>
+              <a:off x="5893870" y="2883066"/>
+              <a:ext cx="144379" cy="707886"/>
+            </a:xfrm>
+            <a:prstGeom prst="rect">
+              <a:avLst/>
+            </a:prstGeom>
+            <a:noFill/>
+          </p:spPr>
+          <p:txBody>
+            <a:bodyPr wrap="square">
+              <a:spAutoFit/>
+            </a:bodyPr>
+            <a:lstStyle/>
+            <a:p>
+              <a:pPr lvl="1" algn="ctr">
+                <a:buClr>
+                  <a:schemeClr val="bg1"/>
+                </a:buClr>
+                <a:buSzPct val="120000"/>
+              </a:pPr>
+              <a:r>
+                <a:rPr lang="bg-BG" sz="4000" dirty="0">
+                  <a:solidFill>
+                    <a:schemeClr val="bg1"/>
+                  </a:solidFill>
+                  <a:latin typeface="Montserrat" panose="00000500000000000000" pitchFamily="2" charset="0"/>
+                </a:rPr>
+                <a:t>)</a:t>
+              </a:r>
+              <a:endParaRPr lang="bg-BG" sz="4000" dirty="0">
+                <a:solidFill>
+                  <a:schemeClr val="bg1"/>
+                </a:solidFill>
+                <a:effectLst/>
+                <a:latin typeface="Montserrat" panose="00000500000000000000" pitchFamily="2" charset="0"/>
+              </a:endParaRPr>
+            </a:p>
+          </p:txBody>
+        </p:sp>
+        <p:sp>
+          <p:nvSpPr>
+            <p:cNvPr id="9" name="TextBox 8">
+              <a:extLst>
+                <a:ext uri="{FF2B5EF4-FFF2-40B4-BE49-F238E27FC236}">
+                  <a16:creationId xmlns:a16="http://schemas.microsoft.com/office/drawing/2014/main" id="{FC700F97-B3E9-85B8-34B1-815C0FA0B9B9}"/>
+                </a:ext>
+              </a:extLst>
+            </p:cNvPr>
+            <p:cNvSpPr txBox="1"/>
+            <p:nvPr/>
+          </p:nvSpPr>
+          <p:spPr>
+            <a:xfrm>
+              <a:off x="605675" y="2863394"/>
+              <a:ext cx="577516" cy="707886"/>
+            </a:xfrm>
+            <a:prstGeom prst="rect">
+              <a:avLst/>
+            </a:prstGeom>
+            <a:noFill/>
+          </p:spPr>
+          <p:txBody>
+            <a:bodyPr wrap="square">
+              <a:spAutoFit/>
+            </a:bodyPr>
+            <a:lstStyle/>
+            <a:p>
+              <a:pPr lvl="1" algn="ctr">
+                <a:buClr>
+                  <a:schemeClr val="bg1"/>
+                </a:buClr>
+                <a:buSzPct val="120000"/>
+              </a:pPr>
+              <a:r>
+                <a:rPr lang="bg-BG" sz="4000" dirty="0">
+                  <a:solidFill>
+                    <a:schemeClr val="bg1"/>
+                  </a:solidFill>
+                  <a:effectLst/>
+                  <a:latin typeface="Montserrat" panose="00000500000000000000" pitchFamily="2" charset="0"/>
+                </a:rPr>
+                <a:t>(</a:t>
+              </a:r>
+            </a:p>
+          </p:txBody>
+        </p:sp>
+      </p:grpSp>
+      <p:pic>
+        <p:nvPicPr>
+          <p:cNvPr id="13" name="Graphic 12" descr="Rocket with solid fill">
+            <a:extLst>
+              <a:ext uri="{FF2B5EF4-FFF2-40B4-BE49-F238E27FC236}">
+                <a16:creationId xmlns:a16="http://schemas.microsoft.com/office/drawing/2014/main" id="{0A4D0CF4-3C00-585D-4EC2-396FAF2C134A}"/>
+              </a:ext>
+            </a:extLst>
+          </p:cNvPr>
+          <p:cNvPicPr>
+            <a:picLocks noChangeAspect="1"/>
+          </p:cNvPicPr>
+          <p:nvPr/>
+        </p:nvPicPr>
+        <p:blipFill>
+          <a:blip r:embed="rId4">
+            <a:extLst>
+              <a:ext uri="{96DAC541-7B7A-43D3-8B79-37D633B846F1}">
+                <asvg:svgBlip xmlns:asvg="http://schemas.microsoft.com/office/drawing/2016/SVG/main" r:embed="rId5"/>
+              </a:ext>
+            </a:extLst>
+          </a:blip>
+          <a:stretch>
+            <a:fillRect/>
+          </a:stretch>
+        </p:blipFill>
+        <p:spPr>
+          <a:xfrm>
+            <a:off x="10993196" y="100178"/>
+            <a:ext cx="1011541" cy="1011541"/>
+          </a:xfrm>
+          <a:prstGeom prst="rect">
+            <a:avLst/>
+          </a:prstGeom>
+        </p:spPr>
+      </p:pic>
+      <p:pic>
+        <p:nvPicPr>
+          <p:cNvPr id="20" name="Picture 19" descr="A close-up of a map&#10;&#10;AI-generated content may be incorrect.">
+            <a:extLst>
+              <a:ext uri="{FF2B5EF4-FFF2-40B4-BE49-F238E27FC236}">
+                <a16:creationId xmlns:a16="http://schemas.microsoft.com/office/drawing/2014/main" id="{E631FF16-9B4E-0AE3-2B96-6C2E66EECE73}"/>
+              </a:ext>
+            </a:extLst>
+          </p:cNvPr>
+          <p:cNvPicPr>
+            <a:picLocks noChangeAspect="1"/>
+          </p:cNvPicPr>
+          <p:nvPr/>
+        </p:nvPicPr>
+        <p:blipFill>
+          <a:blip r:embed="rId6">
+            <a:extLst>
+              <a:ext uri="{28A0092B-C50C-407E-A947-70E740481C1C}">
+                <a14:useLocalDpi xmlns:a14="http://schemas.microsoft.com/office/drawing/2010/main" val="0"/>
+              </a:ext>
+            </a:extLst>
+          </a:blip>
+          <a:srcRect l="5924" t="26783" r="51037" b="15849"/>
+          <a:stretch>
+            <a:fillRect/>
+          </a:stretch>
+        </p:blipFill>
+        <p:spPr>
+          <a:xfrm>
+            <a:off x="7517252" y="1082194"/>
+            <a:ext cx="3345136" cy="2508089"/>
+          </a:xfrm>
+          <a:prstGeom prst="rect">
+            <a:avLst/>
+          </a:prstGeom>
+          <a:effectLst>
+            <a:softEdge rad="38100"/>
+          </a:effectLst>
+        </p:spPr>
+      </p:pic>
+      <p:pic>
+        <p:nvPicPr>
+          <p:cNvPr id="21" name="Picture 20" descr="A close-up of a map&#10;&#10;AI-generated content may be incorrect.">
+            <a:extLst>
+              <a:ext uri="{FF2B5EF4-FFF2-40B4-BE49-F238E27FC236}">
+                <a16:creationId xmlns:a16="http://schemas.microsoft.com/office/drawing/2014/main" id="{3708D5B9-0BB2-D178-753E-608874F6AD5E}"/>
+              </a:ext>
+            </a:extLst>
+          </p:cNvPr>
+          <p:cNvPicPr>
+            <a:picLocks noChangeAspect="1"/>
+          </p:cNvPicPr>
+          <p:nvPr/>
+        </p:nvPicPr>
+        <p:blipFill>
+          <a:blip r:embed="rId6">
+            <a:extLst>
+              <a:ext uri="{28A0092B-C50C-407E-A947-70E740481C1C}">
+                <a14:useLocalDpi xmlns:a14="http://schemas.microsoft.com/office/drawing/2010/main" val="0"/>
+              </a:ext>
+            </a:extLst>
+          </a:blip>
+          <a:srcRect l="52103" t="28440" r="5679" b="17006"/>
+          <a:stretch>
+            <a:fillRect/>
+          </a:stretch>
+        </p:blipFill>
+        <p:spPr>
+          <a:xfrm>
+            <a:off x="7512074" y="3753258"/>
+            <a:ext cx="3359939" cy="2442202"/>
+          </a:xfrm>
+          <a:prstGeom prst="rect">
+            <a:avLst/>
+          </a:prstGeom>
+          <a:effectLst>
+            <a:softEdge rad="38100"/>
+          </a:effectLst>
+        </p:spPr>
+      </p:pic>
+      <p:sp>
+        <p:nvSpPr>
+          <p:cNvPr id="23" name="TextBox 22">
+            <a:extLst>
+              <a:ext uri="{FF2B5EF4-FFF2-40B4-BE49-F238E27FC236}">
+                <a16:creationId xmlns:a16="http://schemas.microsoft.com/office/drawing/2014/main" id="{52E3D7DC-AFA2-3A4B-FA4B-40A875C5457A}"/>
+              </a:ext>
+            </a:extLst>
+          </p:cNvPr>
+          <p:cNvSpPr txBox="1"/>
+          <p:nvPr/>
+        </p:nvSpPr>
+        <p:spPr>
+          <a:xfrm rot="5400000">
+            <a:off x="9717271" y="4605924"/>
+            <a:ext cx="2983831" cy="338554"/>
+          </a:xfrm>
+          <a:prstGeom prst="rect">
+            <a:avLst/>
+          </a:prstGeom>
+          <a:noFill/>
+        </p:spPr>
+        <p:txBody>
+          <a:bodyPr wrap="square">
+            <a:spAutoFit/>
+          </a:bodyPr>
+          <a:lstStyle/>
+          <a:p>
+            <a:pPr lvl="1" algn="ctr">
+              <a:buClr>
+                <a:schemeClr val="bg1"/>
+              </a:buClr>
+              <a:buSzPct val="120000"/>
+            </a:pPr>
+            <a:r>
+              <a:rPr lang="bg-BG" sz="1600" b="1" dirty="0">
+                <a:solidFill>
+                  <a:schemeClr val="bg1"/>
+                </a:solidFill>
+                <a:latin typeface="Montserrat" panose="00000500000000000000" pitchFamily="2" charset="0"/>
+              </a:rPr>
+              <a:t>С </a:t>
+            </a:r>
+            <a:r>
+              <a:rPr lang="en-US" sz="1600" b="1" dirty="0">
+                <a:solidFill>
+                  <a:schemeClr val="bg1"/>
+                </a:solidFill>
+                <a:latin typeface="Montserrat" panose="00000500000000000000" pitchFamily="2" charset="0"/>
+              </a:rPr>
+              <a:t>Gradient clipping</a:t>
+            </a:r>
+          </a:p>
+        </p:txBody>
+      </p:sp>
+      <p:sp>
+        <p:nvSpPr>
+          <p:cNvPr id="24" name="TextBox 23">
+            <a:extLst>
+              <a:ext uri="{FF2B5EF4-FFF2-40B4-BE49-F238E27FC236}">
+                <a16:creationId xmlns:a16="http://schemas.microsoft.com/office/drawing/2014/main" id="{AC0510F3-BC1F-61C7-E2DB-3D5AB6074F23}"/>
+              </a:ext>
+            </a:extLst>
+          </p:cNvPr>
+          <p:cNvSpPr txBox="1"/>
+          <p:nvPr/>
+        </p:nvSpPr>
+        <p:spPr>
+          <a:xfrm rot="5400000">
+            <a:off x="9717270" y="1919333"/>
+            <a:ext cx="2983831" cy="338554"/>
+          </a:xfrm>
+          <a:prstGeom prst="rect">
+            <a:avLst/>
+          </a:prstGeom>
+          <a:noFill/>
+        </p:spPr>
+        <p:txBody>
+          <a:bodyPr wrap="square">
+            <a:spAutoFit/>
+          </a:bodyPr>
+          <a:lstStyle/>
+          <a:p>
+            <a:pPr lvl="1" algn="ctr">
+              <a:buClr>
+                <a:schemeClr val="bg1"/>
+              </a:buClr>
+              <a:buSzPct val="120000"/>
+            </a:pPr>
+            <a:r>
+              <a:rPr lang="bg-BG" sz="1600" b="1" dirty="0">
+                <a:solidFill>
+                  <a:schemeClr val="bg1"/>
+                </a:solidFill>
+                <a:latin typeface="Montserrat" panose="00000500000000000000" pitchFamily="2" charset="0"/>
+              </a:rPr>
+              <a:t>Без </a:t>
+            </a:r>
+            <a:r>
+              <a:rPr lang="en-US" sz="1600" b="1" dirty="0">
+                <a:solidFill>
+                  <a:schemeClr val="bg1"/>
+                </a:solidFill>
+                <a:latin typeface="Montserrat" panose="00000500000000000000" pitchFamily="2" charset="0"/>
+              </a:rPr>
+              <a:t>Gradient clipping</a:t>
+            </a:r>
+          </a:p>
+        </p:txBody>
+      </p:sp>
+    </p:spTree>
+    <p:extLst>
+      <p:ext uri="{BB962C8B-B14F-4D97-AF65-F5344CB8AC3E}">
+        <p14:creationId xmlns:p14="http://schemas.microsoft.com/office/powerpoint/2010/main" val="3208244852"/>
+      </p:ext>
+    </p:extLst>
+  </p:cSld>
+  <p:clrMapOvr>
+    <a:masterClrMapping/>
+  </p:clrMapOvr>
+</p:sld>
+</file>
+
+<file path=ppt/slides/slide9.xml><?xml version="1.0" encoding="utf-8"?>
+<p:sld xmlns:a="http://schemas.openxmlformats.org/drawingml/2006/main" xmlns:r="http://schemas.openxmlformats.org/officeDocument/2006/relationships" xmlns:p="http://schemas.openxmlformats.org/presentationml/2006/main">
+  <p:cSld>
+    <p:spTree>
+      <p:nvGrpSpPr>
+        <p:cNvPr id="1" name="">
+          <a:extLst>
+            <a:ext uri="{FF2B5EF4-FFF2-40B4-BE49-F238E27FC236}">
               <a16:creationId xmlns:a16="http://schemas.microsoft.com/office/drawing/2014/main" id="{B3E55321-0B10-E1D4-E5EB-E17E3A265ED9}"/>
             </a:ext>
           </a:extLst>
@@ -7230,7 +8669,7 @@
                 </a:solidFill>
                 <a:latin typeface="Montserrat" panose="00000500000000000000" pitchFamily="2" charset="0"/>
               </a:rPr>
-              <a:t>7/10</a:t>
+              <a:t>8/10</a:t>
             </a:r>
           </a:p>
         </p:txBody>
@@ -7774,8 +9213,8 @@
           </a:extLst>
         </p:spPr>
       </p:pic>
-      <mc:AlternateContent xmlns:mc="http://schemas.openxmlformats.org/markup-compatibility/2006">
-        <mc:Choice xmlns:a14="http://schemas.microsoft.com/office/drawing/2010/main" Requires="a14">
+      <mc:AlternateContent xmlns:mc="http://schemas.openxmlformats.org/markup-compatibility/2006" xmlns:a14="http://schemas.microsoft.com/office/drawing/2010/main">
+        <mc:Choice Requires="a14">
           <p:sp>
             <p:nvSpPr>
               <p:cNvPr id="9" name="TextBox 8">
@@ -7804,6 +9243,7 @@
               </a:bodyPr>
               <a:lstStyle/>
               <a:p>
+                <a:pPr/>
                 <a14:m>
                   <m:oMathPara xmlns:m="http://schemas.openxmlformats.org/officeDocument/2006/math">
                     <m:oMathParaPr>
@@ -7969,7 +9409,7 @@
             </p:txBody>
           </p:sp>
         </mc:Choice>
-        <mc:Fallback>
+        <mc:Fallback xmlns="">
           <p:sp>
             <p:nvSpPr>
               <p:cNvPr id="9" name="TextBox 8">
@@ -8018,529 +9458,6 @@
     <p:extLst>
       <p:ext uri="{BB962C8B-B14F-4D97-AF65-F5344CB8AC3E}">
         <p14:creationId xmlns:p14="http://schemas.microsoft.com/office/powerpoint/2010/main" val="4137978096"/>
-      </p:ext>
-    </p:extLst>
-  </p:cSld>
-  <p:clrMapOvr>
-    <a:masterClrMapping/>
-  </p:clrMapOvr>
-</p:sld>
-</file>
-
-<file path=ppt/slides/slide9.xml><?xml version="1.0" encoding="utf-8"?>
-<p:sld xmlns:a="http://schemas.openxmlformats.org/drawingml/2006/main" xmlns:r="http://schemas.openxmlformats.org/officeDocument/2006/relationships" xmlns:p="http://schemas.openxmlformats.org/presentationml/2006/main">
-  <p:cSld>
-    <p:spTree>
-      <p:nvGrpSpPr>
-        <p:cNvPr id="1" name="">
-          <a:extLst>
-            <a:ext uri="{FF2B5EF4-FFF2-40B4-BE49-F238E27FC236}">
-              <a16:creationId xmlns:a16="http://schemas.microsoft.com/office/drawing/2014/main" id="{C33651CE-39D7-A105-5EEF-AED97F7BF0E2}"/>
-            </a:ext>
-          </a:extLst>
-        </p:cNvPr>
-        <p:cNvGrpSpPr/>
-        <p:nvPr/>
-      </p:nvGrpSpPr>
-      <p:grpSpPr>
-        <a:xfrm>
-          <a:off x="0" y="0"/>
-          <a:ext cx="0" cy="0"/>
-          <a:chOff x="0" y="0"/>
-          <a:chExt cx="0" cy="0"/>
-        </a:xfrm>
-      </p:grpSpPr>
-      <p:pic>
-        <p:nvPicPr>
-          <p:cNvPr id="18" name="Picture 2" descr="High resolution abstract digital background with connected white dots and multicolor light effects on black background">
-            <a:extLst>
-              <a:ext uri="{FF2B5EF4-FFF2-40B4-BE49-F238E27FC236}">
-                <a16:creationId xmlns:a16="http://schemas.microsoft.com/office/drawing/2014/main" id="{47E619C3-2E5E-6FFD-2438-570D3CB917BC}"/>
-              </a:ext>
-            </a:extLst>
-          </p:cNvPr>
-          <p:cNvPicPr>
-            <a:picLocks noChangeAspect="1" noChangeArrowheads="1"/>
-          </p:cNvPicPr>
-          <p:nvPr/>
-        </p:nvPicPr>
-        <p:blipFill rotWithShape="1">
-          <a:blip r:embed="rId2">
-            <a:extLst>
-              <a:ext uri="{28A0092B-C50C-407E-A947-70E740481C1C}">
-                <a14:useLocalDpi xmlns:a14="http://schemas.microsoft.com/office/drawing/2010/main" val="0"/>
-              </a:ext>
-            </a:extLst>
-          </a:blip>
-          <a:srcRect l="50433"/>
-          <a:stretch/>
-        </p:blipFill>
-        <p:spPr bwMode="auto">
-          <a:xfrm rot="4230197" flipH="1">
-            <a:off x="8701876" y="65715"/>
-            <a:ext cx="2553258" cy="3653108"/>
-          </a:xfrm>
-          <a:prstGeom prst="rect">
-            <a:avLst/>
-          </a:prstGeom>
-          <a:noFill/>
-          <a:extLst>
-            <a:ext uri="{909E8E84-426E-40DD-AFC4-6F175D3DCCD1}">
-              <a14:hiddenFill xmlns:a14="http://schemas.microsoft.com/office/drawing/2010/main">
-                <a:solidFill>
-                  <a:srgbClr val="FFFFFF"/>
-                </a:solidFill>
-              </a14:hiddenFill>
-            </a:ext>
-          </a:extLst>
-        </p:spPr>
-      </p:pic>
-      <p:sp>
-        <p:nvSpPr>
-          <p:cNvPr id="3" name="TextBox 2">
-            <a:extLst>
-              <a:ext uri="{FF2B5EF4-FFF2-40B4-BE49-F238E27FC236}">
-                <a16:creationId xmlns:a16="http://schemas.microsoft.com/office/drawing/2014/main" id="{B9628755-65BA-DD6E-C74F-1673BE5799ED}"/>
-              </a:ext>
-            </a:extLst>
-          </p:cNvPr>
-          <p:cNvSpPr txBox="1"/>
-          <p:nvPr/>
-        </p:nvSpPr>
-        <p:spPr>
-          <a:xfrm>
-            <a:off x="10671142" y="6404610"/>
-            <a:ext cx="1520858" cy="461665"/>
-          </a:xfrm>
-          <a:prstGeom prst="rect">
-            <a:avLst/>
-          </a:prstGeom>
-          <a:noFill/>
-        </p:spPr>
-        <p:txBody>
-          <a:bodyPr wrap="square" rtlCol="0">
-            <a:spAutoFit/>
-          </a:bodyPr>
-          <a:lstStyle/>
-          <a:p>
-            <a:pPr algn="ctr"/>
-            <a:r>
-              <a:rPr lang="en-US" sz="2400" b="1" dirty="0">
-                <a:solidFill>
-                  <a:schemeClr val="bg1"/>
-                </a:solidFill>
-                <a:latin typeface="Montserrat" panose="00000500000000000000" pitchFamily="2" charset="0"/>
-              </a:rPr>
-              <a:t>8/10</a:t>
-            </a:r>
-          </a:p>
-        </p:txBody>
-      </p:sp>
-      <p:pic>
-        <p:nvPicPr>
-          <p:cNvPr id="5" name="Graphic 4">
-            <a:extLst>
-              <a:ext uri="{FF2B5EF4-FFF2-40B4-BE49-F238E27FC236}">
-                <a16:creationId xmlns:a16="http://schemas.microsoft.com/office/drawing/2014/main" id="{FAC18E02-D78F-5FA1-48E1-1A5CCAFFC294}"/>
-              </a:ext>
-            </a:extLst>
-          </p:cNvPr>
-          <p:cNvPicPr>
-            <a:picLocks noChangeAspect="1"/>
-          </p:cNvPicPr>
-          <p:nvPr/>
-        </p:nvPicPr>
-        <p:blipFill>
-          <a:blip r:embed="rId3">
-            <a:extLst>
-              <a:ext uri="{96DAC541-7B7A-43D3-8B79-37D633B846F1}">
-                <asvg:svgBlip xmlns:asvg="http://schemas.microsoft.com/office/drawing/2016/SVG/main" r:embed="rId4"/>
-              </a:ext>
-            </a:extLst>
-          </a:blip>
-          <a:stretch>
-            <a:fillRect/>
-          </a:stretch>
-        </p:blipFill>
-        <p:spPr>
-          <a:xfrm>
-            <a:off x="3001648" y="0"/>
-            <a:ext cx="6188703" cy="6858000"/>
-          </a:xfrm>
-          <a:prstGeom prst="rect">
-            <a:avLst/>
-          </a:prstGeom>
-        </p:spPr>
-      </p:pic>
-      <p:pic>
-        <p:nvPicPr>
-          <p:cNvPr id="10" name="Graphic 9">
-            <a:extLst>
-              <a:ext uri="{FF2B5EF4-FFF2-40B4-BE49-F238E27FC236}">
-                <a16:creationId xmlns:a16="http://schemas.microsoft.com/office/drawing/2014/main" id="{36CBB482-CF4E-95C3-3513-3A30621CEF48}"/>
-              </a:ext>
-            </a:extLst>
-          </p:cNvPr>
-          <p:cNvPicPr>
-            <a:picLocks noChangeAspect="1"/>
-          </p:cNvPicPr>
-          <p:nvPr/>
-        </p:nvPicPr>
-        <p:blipFill>
-          <a:blip r:embed="rId3">
-            <a:extLst>
-              <a:ext uri="{96DAC541-7B7A-43D3-8B79-37D633B846F1}">
-                <asvg:svgBlip xmlns:asvg="http://schemas.microsoft.com/office/drawing/2016/SVG/main" r:embed="rId4"/>
-              </a:ext>
-            </a:extLst>
-          </a:blip>
-          <a:stretch>
-            <a:fillRect/>
-          </a:stretch>
-        </p:blipFill>
-        <p:spPr>
-          <a:xfrm>
-            <a:off x="4337497" y="-1253765"/>
-            <a:ext cx="6188703" cy="6858000"/>
-          </a:xfrm>
-          <a:prstGeom prst="rect">
-            <a:avLst/>
-          </a:prstGeom>
-        </p:spPr>
-      </p:pic>
-      <p:pic>
-        <p:nvPicPr>
-          <p:cNvPr id="15" name="Picture 2" descr="High resolution abstract digital background with connected white dots and multicolor light effects on black background">
-            <a:extLst>
-              <a:ext uri="{FF2B5EF4-FFF2-40B4-BE49-F238E27FC236}">
-                <a16:creationId xmlns:a16="http://schemas.microsoft.com/office/drawing/2014/main" id="{92B5975D-9837-71DA-536E-1FE2BA54584A}"/>
-              </a:ext>
-            </a:extLst>
-          </p:cNvPr>
-          <p:cNvPicPr>
-            <a:picLocks noChangeAspect="1" noChangeArrowheads="1"/>
-          </p:cNvPicPr>
-          <p:nvPr/>
-        </p:nvPicPr>
-        <p:blipFill rotWithShape="1">
-          <a:blip r:embed="rId2">
-            <a:extLst>
-              <a:ext uri="{28A0092B-C50C-407E-A947-70E740481C1C}">
-                <a14:useLocalDpi xmlns:a14="http://schemas.microsoft.com/office/drawing/2010/main" val="0"/>
-              </a:ext>
-            </a:extLst>
-          </a:blip>
-          <a:srcRect l="50433"/>
-          <a:stretch/>
-        </p:blipFill>
-        <p:spPr bwMode="auto">
-          <a:xfrm rot="16508661" flipH="1">
-            <a:off x="830915" y="2805991"/>
-            <a:ext cx="2463336" cy="3524451"/>
-          </a:xfrm>
-          <a:prstGeom prst="rect">
-            <a:avLst/>
-          </a:prstGeom>
-          <a:noFill/>
-          <a:extLst>
-            <a:ext uri="{909E8E84-426E-40DD-AFC4-6F175D3DCCD1}">
-              <a14:hiddenFill xmlns:a14="http://schemas.microsoft.com/office/drawing/2010/main">
-                <a:solidFill>
-                  <a:srgbClr val="FFFFFF"/>
-                </a:solidFill>
-              </a14:hiddenFill>
-            </a:ext>
-          </a:extLst>
-        </p:spPr>
-      </p:pic>
-      <p:grpSp>
-        <p:nvGrpSpPr>
-          <p:cNvPr id="9" name="Group 8">
-            <a:extLst>
-              <a:ext uri="{FF2B5EF4-FFF2-40B4-BE49-F238E27FC236}">
-                <a16:creationId xmlns:a16="http://schemas.microsoft.com/office/drawing/2014/main" id="{F2C45289-90D8-241A-C63E-D81224A4354F}"/>
-              </a:ext>
-            </a:extLst>
-          </p:cNvPr>
-          <p:cNvGrpSpPr/>
-          <p:nvPr/>
-        </p:nvGrpSpPr>
-        <p:grpSpPr>
-          <a:xfrm>
-            <a:off x="805990" y="1352510"/>
-            <a:ext cx="10580017" cy="3323987"/>
-            <a:chOff x="805990" y="1523910"/>
-            <a:chExt cx="10580017" cy="3323987"/>
-          </a:xfrm>
-        </p:grpSpPr>
-        <p:sp>
-          <p:nvSpPr>
-            <p:cNvPr id="8" name="TextBox 7">
-              <a:extLst>
-                <a:ext uri="{FF2B5EF4-FFF2-40B4-BE49-F238E27FC236}">
-                  <a16:creationId xmlns:a16="http://schemas.microsoft.com/office/drawing/2014/main" id="{BC482FBF-9716-CA59-7608-C317C4C5AF8C}"/>
-                </a:ext>
-              </a:extLst>
-            </p:cNvPr>
-            <p:cNvSpPr txBox="1"/>
-            <p:nvPr/>
-          </p:nvSpPr>
-          <p:spPr>
-            <a:xfrm>
-              <a:off x="805990" y="1523910"/>
-              <a:ext cx="10580017" cy="1200329"/>
-            </a:xfrm>
-            <a:prstGeom prst="rect">
-              <a:avLst/>
-            </a:prstGeom>
-            <a:noFill/>
-          </p:spPr>
-          <p:txBody>
-            <a:bodyPr wrap="square" rtlCol="0">
-              <a:spAutoFit/>
-            </a:bodyPr>
-            <a:lstStyle/>
-            <a:p>
-              <a:pPr algn="ctr"/>
-              <a:r>
-                <a:rPr lang="bg-BG" sz="7200" b="1" dirty="0">
-                  <a:solidFill>
-                    <a:schemeClr val="bg1"/>
-                  </a:solidFill>
-                  <a:latin typeface="Montserrat" panose="00000500000000000000" pitchFamily="2" charset="0"/>
-                </a:rPr>
-                <a:t>ДЕМОНСТРАЦИЯ</a:t>
-              </a:r>
-              <a:endParaRPr lang="en-US" sz="7200" b="1" dirty="0">
-                <a:solidFill>
-                  <a:schemeClr val="bg1"/>
-                </a:solidFill>
-                <a:latin typeface="Montserrat" panose="00000500000000000000" pitchFamily="2" charset="0"/>
-              </a:endParaRPr>
-            </a:p>
-          </p:txBody>
-        </p:sp>
-        <p:sp>
-          <p:nvSpPr>
-            <p:cNvPr id="2" name="TextBox 1">
-              <a:extLst>
-                <a:ext uri="{FF2B5EF4-FFF2-40B4-BE49-F238E27FC236}">
-                  <a16:creationId xmlns:a16="http://schemas.microsoft.com/office/drawing/2014/main" id="{EE283427-CC39-D6B5-4C8D-FC9E0733A5B2}"/>
-                </a:ext>
-              </a:extLst>
-            </p:cNvPr>
-            <p:cNvSpPr txBox="1"/>
-            <p:nvPr/>
-          </p:nvSpPr>
-          <p:spPr>
-            <a:xfrm>
-              <a:off x="1247775" y="2724239"/>
-              <a:ext cx="9278425" cy="2123658"/>
-            </a:xfrm>
-            <a:prstGeom prst="rect">
-              <a:avLst/>
-            </a:prstGeom>
-            <a:noFill/>
-          </p:spPr>
-          <p:txBody>
-            <a:bodyPr wrap="square" rtlCol="0">
-              <a:spAutoFit/>
-            </a:bodyPr>
-            <a:lstStyle/>
-            <a:p>
-              <a:pPr marL="914400" lvl="1" indent="-457200">
-                <a:buClr>
-                  <a:schemeClr val="bg1"/>
-                </a:buClr>
-                <a:buSzPct val="120000"/>
-                <a:buFont typeface="System Font Regular"/>
-                <a:buChar char="→"/>
-              </a:pPr>
-              <a:r>
-                <a:rPr lang="bg-BG" sz="2400" i="0" dirty="0">
-                  <a:solidFill>
-                    <a:schemeClr val="bg1"/>
-                  </a:solidFill>
-                  <a:effectLst/>
-                  <a:latin typeface="Montserrat" panose="00000500000000000000" pitchFamily="2" charset="0"/>
-                </a:rPr>
-                <a:t>Разпознаване на нарисувани цифри</a:t>
-              </a:r>
-              <a:endParaRPr lang="en-US" sz="2400" i="0" dirty="0">
-                <a:solidFill>
-                  <a:schemeClr val="bg1"/>
-                </a:solidFill>
-                <a:effectLst/>
-                <a:latin typeface="Montserrat" panose="00000500000000000000" pitchFamily="2" charset="0"/>
-              </a:endParaRPr>
-            </a:p>
-            <a:p>
-              <a:pPr marL="914400" lvl="1" indent="-457200">
-                <a:buClr>
-                  <a:schemeClr val="bg1"/>
-                </a:buClr>
-                <a:buSzPct val="120000"/>
-                <a:buFont typeface="System Font Regular"/>
-                <a:buChar char="→"/>
-              </a:pPr>
-              <a:endParaRPr lang="en-US" sz="1200" i="0" dirty="0">
-                <a:solidFill>
-                  <a:schemeClr val="bg1"/>
-                </a:solidFill>
-                <a:effectLst/>
-                <a:latin typeface="Montserrat" panose="00000500000000000000" pitchFamily="2" charset="0"/>
-              </a:endParaRPr>
-            </a:p>
-            <a:p>
-              <a:pPr marL="914400" lvl="1" indent="-457200">
-                <a:buClr>
-                  <a:schemeClr val="bg1"/>
-                </a:buClr>
-                <a:buSzPct val="120000"/>
-                <a:buFont typeface="System Font Regular"/>
-                <a:buChar char="→"/>
-              </a:pPr>
-              <a:r>
-                <a:rPr lang="bg-BG" sz="2400" dirty="0">
-                  <a:solidFill>
-                    <a:schemeClr val="bg1"/>
-                  </a:solidFill>
-                  <a:latin typeface="Montserrat" panose="00000500000000000000" pitchFamily="2" charset="0"/>
-                </a:rPr>
-                <a:t>Визуализация на невронна мрежа</a:t>
-              </a:r>
-              <a:endParaRPr lang="en-US" sz="2400" dirty="0">
-                <a:solidFill>
-                  <a:schemeClr val="bg1"/>
-                </a:solidFill>
-                <a:latin typeface="Montserrat" panose="00000500000000000000" pitchFamily="2" charset="0"/>
-              </a:endParaRPr>
-            </a:p>
-            <a:p>
-              <a:pPr marL="914400" lvl="1" indent="-457200">
-                <a:buClr>
-                  <a:schemeClr val="bg1"/>
-                </a:buClr>
-                <a:buSzPct val="120000"/>
-                <a:buFont typeface="System Font Regular"/>
-                <a:buChar char="→"/>
-              </a:pPr>
-              <a:endParaRPr lang="bg-BG" sz="1200" dirty="0">
-                <a:solidFill>
-                  <a:schemeClr val="bg1"/>
-                </a:solidFill>
-                <a:latin typeface="Montserrat" panose="00000500000000000000" pitchFamily="2" charset="0"/>
-              </a:endParaRPr>
-            </a:p>
-            <a:p>
-              <a:pPr marL="914400" lvl="1" indent="-457200">
-                <a:buClr>
-                  <a:schemeClr val="bg1"/>
-                </a:buClr>
-                <a:buSzPct val="120000"/>
-                <a:buFont typeface="System Font Regular"/>
-                <a:buChar char="→"/>
-              </a:pPr>
-              <a:r>
-                <a:rPr lang="bg-BG" sz="2400" dirty="0">
-                  <a:solidFill>
-                    <a:schemeClr val="bg1"/>
-                  </a:solidFill>
-                  <a:latin typeface="Montserrat" panose="00000500000000000000" pitchFamily="2" charset="0"/>
-                </a:rPr>
-                <a:t>Универсално разпознаване на символи  </a:t>
-              </a:r>
-              <a:endParaRPr lang="en-US" sz="2400" dirty="0">
-                <a:solidFill>
-                  <a:schemeClr val="bg1"/>
-                </a:solidFill>
-                <a:latin typeface="Montserrat" panose="00000500000000000000" pitchFamily="2" charset="0"/>
-              </a:endParaRPr>
-            </a:p>
-            <a:p>
-              <a:pPr marL="914400" lvl="1" indent="-457200">
-                <a:buClr>
-                  <a:schemeClr val="bg1"/>
-                </a:buClr>
-                <a:buSzPct val="120000"/>
-                <a:buFont typeface="System Font Regular"/>
-                <a:buChar char="→"/>
-              </a:pPr>
-              <a:endParaRPr lang="en-US" sz="1200" dirty="0">
-                <a:solidFill>
-                  <a:schemeClr val="bg1"/>
-                </a:solidFill>
-                <a:latin typeface="Montserrat" panose="00000500000000000000" pitchFamily="2" charset="0"/>
-              </a:endParaRPr>
-            </a:p>
-            <a:p>
-              <a:pPr marL="914400" lvl="1" indent="-457200">
-                <a:buClr>
-                  <a:schemeClr val="bg1"/>
-                </a:buClr>
-                <a:buSzPct val="120000"/>
-                <a:buFont typeface="System Font Regular"/>
-                <a:buChar char="→"/>
-              </a:pPr>
-              <a:r>
-                <a:rPr lang="bg-BG" sz="2400" dirty="0">
-                  <a:solidFill>
-                    <a:schemeClr val="bg1"/>
-                  </a:solidFill>
-                  <a:latin typeface="Montserrat" panose="00000500000000000000" pitchFamily="2" charset="0"/>
-                </a:rPr>
-                <a:t>Платформа за решаване на квадратни уравнения</a:t>
-              </a:r>
-              <a:endParaRPr lang="en-US" sz="2400" dirty="0">
-                <a:solidFill>
-                  <a:schemeClr val="bg1"/>
-                </a:solidFill>
-                <a:latin typeface="Montserrat" panose="00000500000000000000" pitchFamily="2" charset="0"/>
-              </a:endParaRPr>
-            </a:p>
-          </p:txBody>
-        </p:sp>
-      </p:grpSp>
-      <p:pic>
-        <p:nvPicPr>
-          <p:cNvPr id="4" name="Picture 3" descr="A blue and green connected circles&#10;&#10;AI-generated content may be incorrect.">
-            <a:extLst>
-              <a:ext uri="{FF2B5EF4-FFF2-40B4-BE49-F238E27FC236}">
-                <a16:creationId xmlns:a16="http://schemas.microsoft.com/office/drawing/2014/main" id="{8959D21F-C9F9-1924-0816-344796C5A6E8}"/>
-              </a:ext>
-            </a:extLst>
-          </p:cNvPr>
-          <p:cNvPicPr>
-            <a:picLocks noChangeAspect="1"/>
-          </p:cNvPicPr>
-          <p:nvPr/>
-        </p:nvPicPr>
-        <p:blipFill>
-          <a:blip r:embed="rId5">
-            <a:extLst>
-              <a:ext uri="{28A0092B-C50C-407E-A947-70E740481C1C}">
-                <a14:useLocalDpi xmlns:a14="http://schemas.microsoft.com/office/drawing/2010/main" val="0"/>
-              </a:ext>
-            </a:extLst>
-          </a:blip>
-          <a:stretch>
-            <a:fillRect/>
-          </a:stretch>
-        </p:blipFill>
-        <p:spPr>
-          <a:xfrm>
-            <a:off x="355575" y="338896"/>
-            <a:ext cx="1243757" cy="937506"/>
-          </a:xfrm>
-          <a:prstGeom prst="rect">
-            <a:avLst/>
-          </a:prstGeom>
-        </p:spPr>
-      </p:pic>
-    </p:spTree>
-    <p:extLst>
-      <p:ext uri="{BB962C8B-B14F-4D97-AF65-F5344CB8AC3E}">
-        <p14:creationId xmlns:p14="http://schemas.microsoft.com/office/powerpoint/2010/main" val="2296167999"/>
       </p:ext>
     </p:extLst>
   </p:cSld>

</xml_diff>